<commit_message>
R2: add rigid-jaw tilt diagram (exp2 stock/TPU tilt curves vs 0-deg baseline) beside finray panel; HTML + PPTX
Co-Authored-By: Claude Fable 5 <noreply@anthropic.com>
Claude-Session: https://claude.ai/code/session_017oudrhYNYJJXGqbwKUgFwY
</commit_message>
<xml_diff>
--- a/docs/seminar/MECH609_seminar.pptx
+++ b/docs/seminar/MECH609_seminar.pptx
@@ -5234,168 +5234,6 @@
           </a:p>
         </p:txBody>
       </p:sp>
-      <p:pic>
-        <p:nvPicPr>
-          <p:cNvPr id="6" name="Picture 5" descr="xbias_left.png"/>
-          <p:cNvPicPr>
-            <a:picLocks noChangeAspect="1"/>
-          </p:cNvPicPr>
-          <p:nvPr/>
-        </p:nvPicPr>
-        <p:blipFill>
-          <a:blip r:embed="rId2"/>
-          <a:stretch>
-            <a:fillRect/>
-          </a:stretch>
-        </p:blipFill>
-        <p:spPr>
-          <a:xfrm>
-            <a:off x="502920" y="1280160"/>
-            <a:ext cx="5619515" cy="4480560"/>
-          </a:xfrm>
-          <a:prstGeom prst="rect">
-            <a:avLst/>
-          </a:prstGeom>
-        </p:spPr>
-      </p:pic>
-      <p:sp>
-        <p:nvSpPr>
-          <p:cNvPr id="7" name="TextBox 6"/>
-          <p:cNvSpPr txBox="1"/>
-          <p:nvPr/>
-        </p:nvSpPr>
-        <p:spPr>
-          <a:xfrm>
-            <a:off x="502920" y="5806440"/>
-            <a:ext cx="6400800" cy="457200"/>
-          </a:xfrm>
-          <a:prstGeom prst="rect">
-            <a:avLst/>
-          </a:prstGeom>
-          <a:noFill/>
-        </p:spPr>
-        <p:txBody>
-          <a:bodyPr wrap="square">
-            <a:spAutoFit/>
-          </a:bodyPr>
-          <a:lstStyle/>
-          <a:p>
-            <a:pPr algn="ctr">
-              <a:lnSpc>
-                <a:spcPct val="115000"/>
-              </a:lnSpc>
-            </a:pPr>
-            <a:r>
-              <a:rPr sz="1150" b="0">
-                <a:solidFill>
-                  <a:srgbClr val="4E545E"/>
-                </a:solidFill>
-                <a:latin typeface="Georgia"/>
-              </a:rPr>
-              <a:t>Contact force vs. press depth under ±2.5° tilt, fin-ray variants.</a:t>
-            </a:r>
-          </a:p>
-        </p:txBody>
-      </p:sp>
-      <p:sp>
-        <p:nvSpPr>
-          <p:cNvPr id="8" name="TextBox 7"/>
-          <p:cNvSpPr txBox="1"/>
-          <p:nvPr/>
-        </p:nvSpPr>
-        <p:spPr>
-          <a:xfrm>
-            <a:off x="7223760" y="1554480"/>
-            <a:ext cx="4480560" cy="4389120"/>
-          </a:xfrm>
-          <a:prstGeom prst="rect">
-            <a:avLst/>
-          </a:prstGeom>
-          <a:noFill/>
-        </p:spPr>
-        <p:txBody>
-          <a:bodyPr wrap="square">
-            <a:spAutoFit/>
-          </a:bodyPr>
-          <a:lstStyle/>
-          <a:p>
-            <a:pPr>
-              <a:lnSpc>
-                <a:spcPct val="118000"/>
-              </a:lnSpc>
-              <a:spcAft>
-                <a:spcPts val="1000"/>
-              </a:spcAft>
-            </a:pPr>
-            <a:r>
-              <a:rPr sz="1500">
-                <a:solidFill>
-                  <a:srgbClr val="1B1B1F"/>
-                </a:solidFill>
-                <a:latin typeface="Georgia"/>
-              </a:rPr>
-              <a:t>•  Shallow press: a 5° tilt cuts contact force by 58%</a:t>
-            </a:r>
-          </a:p>
-          <a:p>
-            <a:pPr>
-              <a:lnSpc>
-                <a:spcPct val="118000"/>
-              </a:lnSpc>
-              <a:spcAft>
-                <a:spcPts val="1000"/>
-              </a:spcAft>
-            </a:pPr>
-            <a:r>
-              <a:rPr sz="1500">
-                <a:solidFill>
-                  <a:srgbClr val="1B1B1F"/>
-                </a:solidFill>
-                <a:latin typeface="Georgia"/>
-              </a:rPr>
-              <a:t>•  Deep press: the same tilt changes it by 1%</a:t>
-            </a:r>
-          </a:p>
-          <a:p>
-            <a:pPr>
-              <a:lnSpc>
-                <a:spcPct val="118000"/>
-              </a:lnSpc>
-              <a:spcAft>
-                <a:spcPts val="1000"/>
-              </a:spcAft>
-            </a:pPr>
-            <a:r>
-              <a:rPr sz="1500">
-                <a:solidFill>
-                  <a:srgbClr val="1B1B1F"/>
-                </a:solidFill>
-                <a:latin typeface="Georgia"/>
-              </a:rPr>
-              <a:t>•  Tilting along the gripping direction is direction-dependent at shallow press: flipping the tilt sign changes force 2.4× — the asymmetry also vanishes at depth</a:t>
-            </a:r>
-          </a:p>
-          <a:p>
-            <a:pPr>
-              <a:lnSpc>
-                <a:spcPct val="118000"/>
-              </a:lnSpc>
-              <a:spcAft>
-                <a:spcPts val="1000"/>
-              </a:spcAft>
-            </a:pPr>
-            <a:r>
-              <a:rPr sz="1500">
-                <a:solidFill>
-                  <a:srgbClr val="1B1B1F"/>
-                </a:solidFill>
-                <a:latin typeface="Georgia"/>
-              </a:rPr>
-              <a:t>•  Tilt tolerance is a property of the operating point, not of the finger alone</a:t>
-            </a:r>
-          </a:p>
-        </p:txBody>
-      </p:sp>
       <p:sp>
         <p:nvSpPr>
           <p:cNvPr id="9" name="Rectangle 8"/>
@@ -5479,6 +5317,124 @@
                 <a:latin typeface="Georgia"/>
               </a:rPr>
               <a:t> press deep enough and tilt sensitivity — including its direction dependence — essentially disappears.</a:t>
+            </a:r>
+          </a:p>
+        </p:txBody>
+      </p:sp>
+      <p:pic>
+        <p:nvPicPr>
+          <p:cNvPr id="11" name="Picture 10" descr="image.png"/>
+          <p:cNvPicPr>
+            <a:picLocks noChangeAspect="1"/>
+          </p:cNvPicPr>
+          <p:nvPr/>
+        </p:nvPicPr>
+        <p:blipFill>
+          <a:blip r:embed="rId2"/>
+          <a:stretch>
+            <a:fillRect/>
+          </a:stretch>
+        </p:blipFill>
+        <p:spPr>
+          <a:xfrm>
+            <a:off x="502920" y="1234440"/>
+            <a:ext cx="4297680" cy="3426632"/>
+          </a:xfrm>
+          <a:prstGeom prst="rect">
+            <a:avLst/>
+          </a:prstGeom>
+        </p:spPr>
+      </p:pic>
+      <p:sp>
+        <p:nvSpPr>
+          <p:cNvPr id="12" name="TextBox 11"/>
+          <p:cNvSpPr txBox="1"/>
+          <p:nvPr/>
+        </p:nvSpPr>
+        <p:spPr>
+          <a:xfrm>
+            <a:off x="502920" y="4892040"/>
+            <a:ext cx="4297680" cy="640080"/>
+          </a:xfrm>
+          <a:prstGeom prst="rect">
+            <a:avLst/>
+          </a:prstGeom>
+          <a:noFill/>
+        </p:spPr>
+        <p:txBody>
+          <a:bodyPr wrap="square">
+            <a:spAutoFit/>
+          </a:bodyPr>
+          <a:lstStyle/>
+          <a:p>
+            <a:pPr algn="ctr"/>
+            <a:r>
+              <a:rPr sz="1100">
+                <a:solidFill>
+                  <a:srgbClr val="4E545E"/>
+                </a:solidFill>
+                <a:latin typeface="Georgia"/>
+              </a:rPr>
+              <a:t>Fin-rays under ±2.5° tilt: curves separate at shallow depth, converge at depth. Shallow: 5° tilt cuts force 58%; deep: 1%. Sign flip changes force 2.4× at shallow press only.</a:t>
+            </a:r>
+          </a:p>
+        </p:txBody>
+      </p:sp>
+      <p:pic>
+        <p:nvPicPr>
+          <p:cNvPr id="13" name="Picture 12" descr="pj_tilt_curves.png"/>
+          <p:cNvPicPr>
+            <a:picLocks noChangeAspect="1"/>
+          </p:cNvPicPr>
+          <p:nvPr/>
+        </p:nvPicPr>
+        <p:blipFill>
+          <a:blip r:embed="rId3"/>
+          <a:stretch>
+            <a:fillRect/>
+          </a:stretch>
+        </p:blipFill>
+        <p:spPr>
+          <a:xfrm>
+            <a:off x="5120640" y="1645920"/>
+            <a:ext cx="6583680" cy="2532184"/>
+          </a:xfrm>
+          <a:prstGeom prst="rect">
+            <a:avLst/>
+          </a:prstGeom>
+        </p:spPr>
+      </p:pic>
+      <p:sp>
+        <p:nvSpPr>
+          <p:cNvPr id="14" name="TextBox 13"/>
+          <p:cNvSpPr txBox="1"/>
+          <p:nvPr/>
+        </p:nvSpPr>
+        <p:spPr>
+          <a:xfrm>
+            <a:off x="5120640" y="4526280"/>
+            <a:ext cx="6583680" cy="640080"/>
+          </a:xfrm>
+          <a:prstGeom prst="rect">
+            <a:avLst/>
+          </a:prstGeom>
+          <a:noFill/>
+        </p:spPr>
+        <p:txBody>
+          <a:bodyPr wrap="square">
+            <a:spAutoFit/>
+          </a:bodyPr>
+          <a:lstStyle/>
+          <a:p>
+            <a:pPr algn="ctr"/>
+            <a:r>
+              <a:rPr sz="1100">
+                <a:solidFill>
+                  <a:srgbClr val="4E545E"/>
+                </a:solidFill>
+                <a:latin typeface="Georgia"/>
+              </a:rPr>
+              <a:t>Rigid jaws under the same tilts: slope unchanged — the ≈1 mm window shifts, it does not widen.</a:t>
             </a:r>
           </a:p>
         </p:txBody>

</xml_diff>

<commit_message>
R4: model1/model2 curves aligned at first successful grasp (x=0); 'recalibrated' wording removed; HTML + PPTX
Co-Authored-By: Claude Fable 5 <noreply@anthropic.com>
Claude-Session: https://claude.ai/code/session_017oudrhYNYJJXGqbwKUgFwY
</commit_message>
<xml_diff>
--- a/docs/seminar/MECH609_seminar.pptx
+++ b/docs/seminar/MECH609_seminar.pptx
@@ -6046,149 +6046,6 @@
           </a:p>
         </p:txBody>
       </p:sp>
-      <p:pic>
-        <p:nvPicPr>
-          <p:cNvPr id="6" name="Picture 5" descr="fr18_m1_vs_m2_new_only.png"/>
-          <p:cNvPicPr>
-            <a:picLocks noChangeAspect="1"/>
-          </p:cNvPicPr>
-          <p:nvPr/>
-        </p:nvPicPr>
-        <p:blipFill>
-          <a:blip r:embed="rId2"/>
-          <a:stretch>
-            <a:fillRect/>
-          </a:stretch>
-        </p:blipFill>
-        <p:spPr>
-          <a:xfrm>
-            <a:off x="502920" y="1280160"/>
-            <a:ext cx="6583680" cy="3566160"/>
-          </a:xfrm>
-          <a:prstGeom prst="rect">
-            <a:avLst/>
-          </a:prstGeom>
-        </p:spPr>
-      </p:pic>
-      <p:sp>
-        <p:nvSpPr>
-          <p:cNvPr id="7" name="TextBox 6"/>
-          <p:cNvSpPr txBox="1"/>
-          <p:nvPr/>
-        </p:nvSpPr>
-        <p:spPr>
-          <a:xfrm>
-            <a:off x="502920" y="5806440"/>
-            <a:ext cx="6583680" cy="457200"/>
-          </a:xfrm>
-          <a:prstGeom prst="rect">
-            <a:avLst/>
-          </a:prstGeom>
-          <a:noFill/>
-        </p:spPr>
-        <p:txBody>
-          <a:bodyPr wrap="square">
-            <a:spAutoFit/>
-          </a:bodyPr>
-          <a:lstStyle/>
-          <a:p>
-            <a:pPr algn="ctr">
-              <a:lnSpc>
-                <a:spcPct val="115000"/>
-              </a:lnSpc>
-            </a:pPr>
-            <a:r>
-              <a:rPr sz="1150" b="0">
-                <a:solidFill>
-                  <a:srgbClr val="4E545E"/>
-                </a:solidFill>
-                <a:latin typeface="Georgia"/>
-              </a:rPr>
-              <a:t>Two separately printed copies of the same 18 mm finger design: force vs. depth, zero tilt.</a:t>
-            </a:r>
-          </a:p>
-        </p:txBody>
-      </p:sp>
-      <p:sp>
-        <p:nvSpPr>
-          <p:cNvPr id="8" name="TextBox 7"/>
-          <p:cNvSpPr txBox="1"/>
-          <p:nvPr/>
-        </p:nvSpPr>
-        <p:spPr>
-          <a:xfrm>
-            <a:off x="7315200" y="1737360"/>
-            <a:ext cx="4389120" cy="4389120"/>
-          </a:xfrm>
-          <a:prstGeom prst="rect">
-            <a:avLst/>
-          </a:prstGeom>
-          <a:noFill/>
-        </p:spPr>
-        <p:txBody>
-          <a:bodyPr wrap="square">
-            <a:spAutoFit/>
-          </a:bodyPr>
-          <a:lstStyle/>
-          <a:p>
-            <a:pPr>
-              <a:lnSpc>
-                <a:spcPct val="118000"/>
-              </a:lnSpc>
-              <a:spcAft>
-                <a:spcPts val="1000"/>
-              </a:spcAft>
-            </a:pPr>
-            <a:r>
-              <a:rPr sz="1550">
-                <a:solidFill>
-                  <a:srgbClr val="1B1B1F"/>
-                </a:solidFill>
-                <a:latin typeface="Georgia"/>
-              </a:rPr>
-              <a:t>•  Second print: same curve, shifted ≈ 1 mm / a few N</a:t>
-            </a:r>
-          </a:p>
-          <a:p>
-            <a:pPr>
-              <a:lnSpc>
-                <a:spcPct val="118000"/>
-              </a:lnSpc>
-              <a:spcAft>
-                <a:spcPts val="1000"/>
-              </a:spcAft>
-            </a:pPr>
-            <a:r>
-              <a:rPr sz="1550">
-                <a:solidFill>
-                  <a:srgbClr val="1B1B1F"/>
-                </a:solidFill>
-                <a:latin typeface="Georgia"/>
-              </a:rPr>
-              <a:t>•  Comparable to day-to-day sensor drift</a:t>
-            </a:r>
-          </a:p>
-          <a:p>
-            <a:pPr>
-              <a:lnSpc>
-                <a:spcPct val="118000"/>
-              </a:lnSpc>
-              <a:spcAft>
-                <a:spcPts val="1000"/>
-              </a:spcAft>
-            </a:pPr>
-            <a:r>
-              <a:rPr sz="1550">
-                <a:solidFill>
-                  <a:srgbClr val="1B1B1F"/>
-                </a:solidFill>
-                <a:latin typeface="Georgia"/>
-              </a:rPr>
-              <a:t>•  Small next to the depth effects (Results 1–3)</a:t>
-            </a:r>
-          </a:p>
-        </p:txBody>
-      </p:sp>
       <p:sp>
         <p:nvSpPr>
           <p:cNvPr id="9" name="Rectangle 8"/>
@@ -6272,6 +6129,145 @@
                 <a:latin typeface="Georgia"/>
               </a:rPr>
               <a:t> — manufacturing error does not change any conclusion of this study.</a:t>
+            </a:r>
+          </a:p>
+        </p:txBody>
+      </p:sp>
+      <p:pic>
+        <p:nvPicPr>
+          <p:cNvPr id="11" name="Picture 10" descr="fr18_m1_vs_m2_aligned0.png"/>
+          <p:cNvPicPr>
+            <a:picLocks noChangeAspect="1"/>
+          </p:cNvPicPr>
+          <p:nvPr/>
+        </p:nvPicPr>
+        <p:blipFill>
+          <a:blip r:embed="rId3"/>
+          <a:stretch>
+            <a:fillRect/>
+          </a:stretch>
+        </p:blipFill>
+        <p:spPr>
+          <a:xfrm>
+            <a:off x="502920" y="1280160"/>
+            <a:ext cx="6583680" cy="3566160"/>
+          </a:xfrm>
+          <a:prstGeom prst="rect">
+            <a:avLst/>
+          </a:prstGeom>
+        </p:spPr>
+      </p:pic>
+      <p:sp>
+        <p:nvSpPr>
+          <p:cNvPr id="12" name="TextBox 11"/>
+          <p:cNvSpPr txBox="1"/>
+          <p:nvPr/>
+        </p:nvSpPr>
+        <p:spPr>
+          <a:xfrm>
+            <a:off x="502920" y="5760720"/>
+            <a:ext cx="6583680" cy="548640"/>
+          </a:xfrm>
+          <a:prstGeom prst="rect">
+            <a:avLst/>
+          </a:prstGeom>
+          <a:noFill/>
+        </p:spPr>
+        <p:txBody>
+          <a:bodyPr wrap="square">
+            <a:spAutoFit/>
+          </a:bodyPr>
+          <a:lstStyle/>
+          <a:p>
+            <a:pPr algn="ctr"/>
+            <a:r>
+              <a:rPr sz="1100">
+                <a:solidFill>
+                  <a:srgbClr val="4E545E"/>
+                </a:solidFill>
+                <a:latin typeface="Georgia"/>
+              </a:rPr>
+              <a:t>Depth axes aligned at each model's first successful grasp (zero tilt).</a:t>
+            </a:r>
+          </a:p>
+        </p:txBody>
+      </p:sp>
+      <p:sp>
+        <p:nvSpPr>
+          <p:cNvPr id="13" name="TextBox 12"/>
+          <p:cNvSpPr txBox="1"/>
+          <p:nvPr/>
+        </p:nvSpPr>
+        <p:spPr>
+          <a:xfrm>
+            <a:off x="7315200" y="1737360"/>
+            <a:ext cx="4389120" cy="3200400"/>
+          </a:xfrm>
+          <a:prstGeom prst="rect">
+            <a:avLst/>
+          </a:prstGeom>
+          <a:noFill/>
+        </p:spPr>
+        <p:txBody>
+          <a:bodyPr wrap="square">
+            <a:spAutoFit/>
+          </a:bodyPr>
+          <a:lstStyle/>
+          <a:p>
+            <a:pPr>
+              <a:lnSpc>
+                <a:spcPct val="118000"/>
+              </a:lnSpc>
+              <a:spcAft>
+                <a:spcPts val="1000"/>
+              </a:spcAft>
+            </a:pPr>
+            <a:r>
+              <a:rPr sz="1550">
+                <a:solidFill>
+                  <a:srgbClr val="1B1B1F"/>
+                </a:solidFill>
+                <a:latin typeface="Georgia"/>
+              </a:rPr>
+              <a:t>•  Depth axes aligned at each model's first successful grasp</a:t>
+            </a:r>
+          </a:p>
+          <a:p>
+            <a:pPr>
+              <a:lnSpc>
+                <a:spcPct val="118000"/>
+              </a:lnSpc>
+              <a:spcAft>
+                <a:spcPts val="1000"/>
+              </a:spcAft>
+            </a:pPr>
+            <a:r>
+              <a:rPr sz="1550">
+                <a:solidFill>
+                  <a:srgbClr val="1B1B1F"/>
+                </a:solidFill>
+                <a:latin typeface="Georgia"/>
+              </a:rPr>
+              <a:t>•  Same curve shape; a few newtons apart near the peak</a:t>
+            </a:r>
+          </a:p>
+          <a:p>
+            <a:pPr>
+              <a:lnSpc>
+                <a:spcPct val="118000"/>
+              </a:lnSpc>
+              <a:spcAft>
+                <a:spcPts val="1000"/>
+              </a:spcAft>
+            </a:pPr>
+            <a:r>
+              <a:rPr sz="1550">
+                <a:solidFill>
+                  <a:srgbClr val="1B1B1F"/>
+                </a:solidFill>
+                <a:latin typeface="Georgia"/>
+              </a:rPr>
+              <a:t>•  Difference comparable to day-to-day sensor drift — small next to the depth effects (Results 1–3)</a:t>
             </a:r>
           </a:p>
         </p:txBody>

</xml_diff>

<commit_message>
R4: successes only, curve cut at 13.5mm, similarity band + agreement metric, larger legend, working-range axis label
Co-Authored-By: Claude Fable 5 <noreply@anthropic.com>
Claude-Session: https://claude.ai/code/session_017oudrhYNYJJXGqbwKUgFwY
</commit_message>
<xml_diff>
--- a/docs/seminar/MECH609_seminar.pptx
+++ b/docs/seminar/MECH609_seminar.pptx
@@ -6142,7 +6142,7 @@
           <p:nvPr/>
         </p:nvPicPr>
         <p:blipFill>
-          <a:blip r:embed="rId3"/>
+          <a:blip r:embed="rId5"/>
           <a:stretch>
             <a:fillRect/>
           </a:stretch>
@@ -6187,7 +6187,7 @@
                 </a:solidFill>
                 <a:latin typeface="Georgia"/>
               </a:rPr>
-              <a:t>Depth axes aligned at each model's first successful grasp (zero tilt).</a:t>
+              <a:t>Successful grasps only; each model's working range aligned to start at 0.</a:t>
             </a:r>
           </a:p>
         </p:txBody>
@@ -6229,7 +6229,7 @@
                 </a:solidFill>
                 <a:latin typeface="Georgia"/>
               </a:rPr>
-              <a:t>•  Depth axes aligned at each model's first successful grasp</a:t>
+              <a:t>•  Each model's working range aligned to start at 0</a:t>
             </a:r>
           </a:p>
           <a:p>
@@ -6248,7 +6248,7 @@
                 </a:solidFill>
                 <a:latin typeface="Georgia"/>
               </a:rPr>
-              <a:t>•  Same curve shape; a few newtons apart near the peak</a:t>
+              <a:t>•  Same peak–valley–rise shape; the two agree within +4.1 N on average (RMSE 5.0 N)</a:t>
             </a:r>
           </a:p>
           <a:p>
@@ -6267,7 +6267,7 @@
                 </a:solidFill>
                 <a:latin typeface="Georgia"/>
               </a:rPr>
-              <a:t>•  Difference comparable to day-to-day sensor drift — small next to the depth effects (Results 1–3)</a:t>
+              <a:t>•  Comparable to day-to-day sensor drift — small next to the depth effects (Results 1–3)</a:t>
             </a:r>
           </a:p>
         </p:txBody>

</xml_diff>